<commit_message>
First integration of AI
</commit_message>
<xml_diff>
--- a/Silajdzic_Jones_Plakat.pptx
+++ b/Silajdzic_Jones_Plakat.pptx
@@ -5,10 +5,11 @@
     <p:sldMasterId id="2147483662" r:id="rId4"/>
   </p:sldMasterIdLst>
   <p:notesMasterIdLst>
-    <p:notesMasterId r:id="rId6"/>
+    <p:notesMasterId r:id="rId7"/>
   </p:notesMasterIdLst>
   <p:sldIdLst>
-    <p:sldId id="257" r:id="rId5"/>
+    <p:sldId id="258" r:id="rId5"/>
+    <p:sldId id="257" r:id="rId6"/>
   </p:sldIdLst>
   <p:sldSz cx="30275213" cy="21383625"/>
   <p:notesSz cx="6858000" cy="9144000"/>
@@ -118,13 +119,52 @@
 <file path=ppt/revisionInfo.xml><?xml version="1.0" encoding="utf-8"?>
 <p1510:revInfo xmlns:a="http://schemas.openxmlformats.org/drawingml/2006/main" xmlns:r="http://schemas.openxmlformats.org/officeDocument/2006/relationships" xmlns:p1510="http://schemas.microsoft.com/office/powerpoint/2015/10/main">
   <p1510:revLst>
-    <p1510:client id="{28B62A79-6EF4-4A42-B6D4-4FC75E82965B}" v="26" dt="2025-11-26T07:45:39.233"/>
+    <p1510:client id="{22AADB22-53F5-49B1-869F-5D23E6892312}" v="38" dt="2025-12-05T16:47:27.713"/>
   </p1510:revLst>
 </p1510:revInfo>
 </file>
 
 <file path=ppt/changesInfos/changesInfo1.xml><?xml version="1.0" encoding="utf-8"?>
 <pc:chgInfo xmlns:a="http://schemas.openxmlformats.org/drawingml/2006/main" xmlns:r="http://schemas.openxmlformats.org/officeDocument/2006/relationships" xmlns:ac="http://schemas.microsoft.com/office/drawing/2013/main/command" xmlns:pc="http://schemas.microsoft.com/office/powerpoint/2013/main/command">
+  <pc:docChgLst>
+    <pc:chgData name="Daniel Jones" userId="05fd09ff656560cc" providerId="LiveId" clId="{48F5BBED-CD52-40F0-B7C6-59A18EF4B9A4}"/>
+    <pc:docChg chg="addSld modSld">
+      <pc:chgData name="Daniel Jones" userId="05fd09ff656560cc" providerId="LiveId" clId="{48F5BBED-CD52-40F0-B7C6-59A18EF4B9A4}" dt="2025-12-05T16:47:27.713" v="40"/>
+      <pc:docMkLst>
+        <pc:docMk/>
+      </pc:docMkLst>
+      <pc:sldChg chg="modTransition modAnim">
+        <pc:chgData name="Daniel Jones" userId="05fd09ff656560cc" providerId="LiveId" clId="{48F5BBED-CD52-40F0-B7C6-59A18EF4B9A4}" dt="2025-12-05T16:47:27.713" v="40"/>
+        <pc:sldMkLst>
+          <pc:docMk/>
+          <pc:sldMk cId="1204506291" sldId="257"/>
+        </pc:sldMkLst>
+      </pc:sldChg>
+      <pc:sldChg chg="addSp modSp new mod">
+        <pc:chgData name="Daniel Jones" userId="05fd09ff656560cc" providerId="LiveId" clId="{48F5BBED-CD52-40F0-B7C6-59A18EF4B9A4}" dt="2025-12-05T16:43:58.628" v="7" actId="1076"/>
+        <pc:sldMkLst>
+          <pc:docMk/>
+          <pc:sldMk cId="1506617824" sldId="258"/>
+        </pc:sldMkLst>
+        <pc:spChg chg="add mod">
+          <ac:chgData name="Daniel Jones" userId="05fd09ff656560cc" providerId="LiveId" clId="{48F5BBED-CD52-40F0-B7C6-59A18EF4B9A4}" dt="2025-12-05T16:42:30.614" v="3" actId="207"/>
+          <ac:spMkLst>
+            <pc:docMk/>
+            <pc:sldMk cId="1506617824" sldId="258"/>
+            <ac:spMk id="2" creationId="{FF5FF567-BE77-2D3A-04FA-F7CEB712174F}"/>
+          </ac:spMkLst>
+        </pc:spChg>
+        <pc:picChg chg="add mod">
+          <ac:chgData name="Daniel Jones" userId="05fd09ff656560cc" providerId="LiveId" clId="{48F5BBED-CD52-40F0-B7C6-59A18EF4B9A4}" dt="2025-12-05T16:43:58.628" v="7" actId="1076"/>
+          <ac:picMkLst>
+            <pc:docMk/>
+            <pc:sldMk cId="1506617824" sldId="258"/>
+            <ac:picMk id="1026" creationId="{E885143B-39D0-9487-0ECF-057FAB75948F}"/>
+          </ac:picMkLst>
+        </pc:picChg>
+      </pc:sldChg>
+    </pc:docChg>
+  </pc:docChgLst>
   <pc:docChgLst>
     <pc:chgData name="Kevin Silajdzic" userId="d2e2836cfd35c8f3" providerId="LiveId" clId="{57371E0D-1E80-4DA4-B097-74EE63E4A05A}"/>
     <pc:docChg chg="undo custSel delSld modSld">
@@ -218,14 +258,6 @@
             <ac:picMk id="3" creationId="{C97BB7E7-8961-AA28-58EC-DB2A96F9C393}"/>
           </ac:picMkLst>
         </pc:picChg>
-        <pc:picChg chg="add del mod">
-          <ac:chgData name="Kevin Silajdzic" userId="d2e2836cfd35c8f3" providerId="LiveId" clId="{57371E0D-1E80-4DA4-B097-74EE63E4A05A}" dt="2025-11-26T07:09:00.929" v="492" actId="478"/>
-          <ac:picMkLst>
-            <pc:docMk/>
-            <pc:sldMk cId="1204506291" sldId="257"/>
-            <ac:picMk id="21" creationId="{A81F28FF-8119-E61C-CAE8-59D0D75122D8}"/>
-          </ac:picMkLst>
-        </pc:picChg>
       </pc:sldChg>
     </pc:docChg>
   </pc:docChgLst>
@@ -323,7 +355,7 @@
           <a:p>
             <a:fld id="{E3D82327-8AB2-764B-A726-DEEEC9C695BA}" type="datetimeFigureOut">
               <a:rPr lang="de-DE" smtClean="0"/>
-              <a:t>26.11.2025</a:t>
+              <a:t>05.12.2025</a:t>
             </a:fld>
             <a:endParaRPr lang="de-DE"/>
           </a:p>
@@ -1725,6 +1757,132 @@
       </p:grpSpPr>
       <p:sp>
         <p:nvSpPr>
+          <p:cNvPr id="2" name="Rechteck 1">
+            <a:extLst>
+              <a:ext uri="{FF2B5EF4-FFF2-40B4-BE49-F238E27FC236}">
+                <a16:creationId xmlns:a16="http://schemas.microsoft.com/office/drawing/2014/main" id="{FF5FF567-BE77-2D3A-04FA-F7CEB712174F}"/>
+              </a:ext>
+            </a:extLst>
+          </p:cNvPr>
+          <p:cNvSpPr/>
+          <p:nvPr/>
+        </p:nvSpPr>
+        <p:spPr>
+          <a:xfrm>
+            <a:off x="0" y="0"/>
+            <a:ext cx="30833568" cy="21383625"/>
+          </a:xfrm>
+          <a:prstGeom prst="rect">
+            <a:avLst/>
+          </a:prstGeom>
+          <a:solidFill>
+            <a:schemeClr val="tx1"/>
+          </a:solidFill>
+        </p:spPr>
+        <p:style>
+          <a:lnRef idx="2">
+            <a:schemeClr val="accent1">
+              <a:shade val="15000"/>
+            </a:schemeClr>
+          </a:lnRef>
+          <a:fillRef idx="1">
+            <a:schemeClr val="accent1"/>
+          </a:fillRef>
+          <a:effectRef idx="0">
+            <a:schemeClr val="accent1"/>
+          </a:effectRef>
+          <a:fontRef idx="minor">
+            <a:schemeClr val="lt1"/>
+          </a:fontRef>
+        </p:style>
+        <p:txBody>
+          <a:bodyPr rtlCol="0" anchor="ctr"/>
+          <a:lstStyle/>
+          <a:p>
+            <a:pPr algn="ctr"/>
+            <a:endParaRPr lang="de-AT"/>
+          </a:p>
+        </p:txBody>
+      </p:sp>
+      <p:pic>
+        <p:nvPicPr>
+          <p:cNvPr id="1026" name="Picture 2" descr="Vorhang auf – Kino-Vorhänge finden und aufhängen | Heimkino Praxis">
+            <a:extLst>
+              <a:ext uri="{FF2B5EF4-FFF2-40B4-BE49-F238E27FC236}">
+                <a16:creationId xmlns:a16="http://schemas.microsoft.com/office/drawing/2014/main" id="{E885143B-39D0-9487-0ECF-057FAB75948F}"/>
+              </a:ext>
+            </a:extLst>
+          </p:cNvPr>
+          <p:cNvPicPr>
+            <a:picLocks noChangeAspect="1" noChangeArrowheads="1"/>
+          </p:cNvPicPr>
+          <p:nvPr/>
+        </p:nvPicPr>
+        <p:blipFill>
+          <a:blip r:embed="rId2">
+            <a:extLst>
+              <a:ext uri="{28A0092B-C50C-407E-A947-70E740481C1C}">
+                <a14:useLocalDpi xmlns:a14="http://schemas.microsoft.com/office/drawing/2010/main" val="0"/>
+              </a:ext>
+            </a:extLst>
+          </a:blip>
+          <a:srcRect/>
+          <a:stretch>
+            <a:fillRect/>
+          </a:stretch>
+        </p:blipFill>
+        <p:spPr bwMode="auto">
+          <a:xfrm>
+            <a:off x="-438912" y="-1"/>
+            <a:ext cx="32075438" cy="21383625"/>
+          </a:xfrm>
+          <a:prstGeom prst="rect">
+            <a:avLst/>
+          </a:prstGeom>
+          <a:noFill/>
+          <a:extLst>
+            <a:ext uri="{909E8E84-426E-40DD-AFC4-6F175D3DCCD1}">
+              <a14:hiddenFill xmlns:a14="http://schemas.microsoft.com/office/drawing/2010/main">
+                <a:solidFill>
+                  <a:srgbClr val="FFFFFF"/>
+                </a:solidFill>
+              </a14:hiddenFill>
+            </a:ext>
+          </a:extLst>
+        </p:spPr>
+      </p:pic>
+    </p:spTree>
+    <p:extLst>
+      <p:ext uri="{BB962C8B-B14F-4D97-AF65-F5344CB8AC3E}">
+        <p14:creationId xmlns:p14="http://schemas.microsoft.com/office/powerpoint/2010/main" val="1506617824"/>
+      </p:ext>
+    </p:extLst>
+  </p:cSld>
+  <p:clrMapOvr>
+    <a:masterClrMapping/>
+  </p:clrMapOvr>
+</p:sld>
+</file>
+
+<file path=ppt/slides/slide2.xml><?xml version="1.0" encoding="utf-8"?>
+<p:sld xmlns:a="http://schemas.openxmlformats.org/drawingml/2006/main" xmlns:r="http://schemas.openxmlformats.org/officeDocument/2006/relationships" xmlns:p="http://schemas.openxmlformats.org/presentationml/2006/main">
+  <p:cSld>
+    <p:spTree>
+      <p:nvGrpSpPr>
+        <p:cNvPr id="1" name=""/>
+        <p:cNvGrpSpPr/>
+        <p:nvPr/>
+      </p:nvGrpSpPr>
+      <p:grpSpPr>
+        <a:xfrm>
+          <a:off x="0" y="0"/>
+          <a:ext cx="0" cy="0"/>
+          <a:chOff x="0" y="0"/>
+          <a:chExt cx="0" cy="0"/>
+        </a:xfrm>
+      </p:grpSpPr>
+      <p:sp>
+        <p:nvSpPr>
           <p:cNvPr id="9" name="Title Placeholder 1"/>
           <p:cNvSpPr txBox="1">
             <a:spLocks/>
@@ -2348,6 +2506,203 @@
   <p:clrMapOvr>
     <a:masterClrMapping/>
   </p:clrMapOvr>
+  <mc:AlternateContent xmlns:mc="http://schemas.openxmlformats.org/markup-compatibility/2006">
+    <mc:Choice xmlns:p15="http://schemas.microsoft.com/office/powerpoint/2012/main" Requires="p15">
+      <p:transition xmlns:p14="http://schemas.microsoft.com/office/powerpoint/2010/main" spd="slow" p14:dur="6000">
+        <p15:prstTrans prst="curtains"/>
+      </p:transition>
+    </mc:Choice>
+    <mc:Fallback>
+      <p:transition spd="slow">
+        <p:fade/>
+      </p:transition>
+    </mc:Fallback>
+  </mc:AlternateContent>
+  <p:timing>
+    <p:tnLst>
+      <p:par>
+        <p:cTn id="1" dur="indefinite" restart="never" nodeType="tmRoot">
+          <p:childTnLst>
+            <p:seq concurrent="1" nextAc="seek">
+              <p:cTn id="2" dur="indefinite" nodeType="mainSeq">
+                <p:childTnLst>
+                  <p:par>
+                    <p:cTn id="3" fill="hold">
+                      <p:stCondLst>
+                        <p:cond delay="indefinite"/>
+                        <p:cond evt="onBegin" delay="0">
+                          <p:tn val="2"/>
+                        </p:cond>
+                      </p:stCondLst>
+                      <p:childTnLst>
+                        <p:par>
+                          <p:cTn id="4" fill="hold">
+                            <p:stCondLst>
+                              <p:cond delay="0"/>
+                            </p:stCondLst>
+                            <p:childTnLst>
+                              <p:par>
+                                <p:cTn id="5" presetID="0" presetClass="path" presetSubtype="0" accel="50000" decel="50000" fill="hold" nodeType="withEffect">
+                                  <p:stCondLst>
+                                    <p:cond delay="0"/>
+                                  </p:stCondLst>
+                                  <p:childTnLst>
+                                    <p:animMotion origin="layout" path="M -0.11189 0.20787 L -0.11189 0.20787 C -0.1464 0.21336 -0.11839 0.20787 -0.19039 0.24038 C -0.19558 0.24276 -0.20067 0.24632 -0.20607 0.24721 C -0.23344 0.25182 -0.21975 0.25011 -0.24718 0.25241 L -0.30879 0.23868 C -0.3197 0.23615 -0.33123 0.2363 -0.3414 0.23014 C -0.36101 0.21834 -0.37124 0.19428 -0.38367 0.17201 C -0.38645 0.15894 -0.39006 0.14484 -0.3897 0.13096 C -0.38949 0.12331 -0.38786 0.11589 -0.38608 0.10868 C -0.38094 0.08827 -0.378 0.07943 -0.36552 0.06763 C -0.36269 0.06496 -0.35907 0.06422 -0.35588 0.06251 C -0.34502 0.06533 -0.33391 0.06674 -0.32326 0.07105 C -0.31456 0.07461 -0.31141 0.08292 -0.30758 0.09332 C -0.30486 0.10052 -0.29993 0.11856 -0.29788 0.12576 C -0.29778 0.12665 -0.29673 0.14172 -0.29426 0.14291 C -0.29306 0.1435 -0.29332 0.13957 -0.29306 0.13779 C -0.29211 0.13155 -0.29159 0.12517 -0.29065 0.11893 C -0.2896 0.11203 -0.28813 0.10527 -0.28703 0.09844 C -0.27701 0.0369 -0.29059 0.11514 -0.27859 0.04714 C -0.27817 0.04024 -0.27811 0.03333 -0.27738 0.02658 C -0.27649 0.01908 -0.27481 0.0118 -0.27371 0.00438 C -0.27277 -0.00245 -0.27203 -0.00928 -0.2713 -0.01619 C -0.26742 -0.05501 -0.26972 -0.05011 -0.26165 -0.1 C -0.25845 -0.11997 -0.25724 -0.14083 -0.252 -0.15984 C -0.24838 -0.17298 -0.24508 -0.18627 -0.24109 -0.19918 C -0.23826 -0.20854 -0.23564 -0.21826 -0.23145 -0.22658 C -0.22741 -0.23452 -0.21697 -0.2444 -0.21094 -0.25048 C -0.19778 -0.24996 -0.1734 -0.2513 -0.15777 -0.24536 C -0.15636 -0.24484 -0.15536 -0.24313 -0.15416 -0.24195 C -0.15243 -0.23831 -0.15012 -0.23319 -0.14813 -0.22999 C -0.14624 -0.22695 -0.14409 -0.22428 -0.14204 -0.22146 C -0.14084 -0.21745 -0.13921 -0.21366 -0.13843 -0.2095 C -0.13544 -0.1925 -0.13869 -0.16674 -0.14084 -0.15301 C -0.14157 -0.14855 -0.14414 -0.14514 -0.14571 -0.14106 C -0.14739 -0.13653 -0.14907 -0.132 -0.15054 -0.1274 C -0.15269 -0.12064 -0.15437 -0.11359 -0.15657 -0.10683 C -0.15882 -0.09985 -0.16171 -0.09339 -0.1638 -0.08634 C -0.1702 -0.06481 -0.17796 -0.04388 -0.18195 -0.02131 C -0.1885 0.01603 -0.18457 -0.00282 -0.19401 0.03511 C -0.19679 0.06652 -0.19626 0.05679 -0.19762 0.08649 C -0.19846 0.10468 -0.20171 0.12309 -0.20004 0.1412 C -0.19972 0.14462 -0.19521 0.14001 -0.1928 0.13949 C -0.18997 0.13437 -0.18745 0.12888 -0.18436 0.12405 C -0.17817 0.11462 -0.17104 0.10646 -0.16501 0.09673 C -0.16218 0.09213 -0.15924 0.08775 -0.15657 0.083 C -0.15442 0.07921 -0.1529 0.07468 -0.15054 0.07105 C -0.14425 0.06147 -0.13827 0.05694 -0.13119 0.04885 C -0.12789 0.04499 -0.12532 0.03972 -0.12154 0.03682 C -0.11546 0.03222 -0.10864 0.03007 -0.10219 0.02658 C -0.09045 0.02027 -0.10219 0.02598 -0.08893 0.01975 C -0.08767 0.02019 -0.07545 0.02383 -0.0732 0.02658 C -0.07183 0.02821 -0.07167 0.03118 -0.07078 0.03341 C -0.0701 0.03519 -0.06921 0.03682 -0.06837 0.03853 C -0.06381 0.06132 -0.06381 0.05642 -0.06717 0.09332 C -0.06753 0.0971 -0.06947 0.10022 -0.07078 0.10356 C -0.07351 0.11047 -0.07613 0.11752 -0.07928 0.12405 C -0.08085 0.12754 -0.08211 0.13133 -0.0841 0.13437 C -0.0862 0.13764 -0.08908 0.13972 -0.09134 0.14291 C -0.10298 0.15939 -0.0884 0.1441 -0.1034 0.15828 C -0.10665 0.16459 -0.11006 0.17067 -0.1131 0.17713 C -0.11467 0.18055 -0.11609 0.18419 -0.11792 0.18738 C -0.11934 0.1899 -0.12123 0.19176 -0.12275 0.19421 C -0.12495 0.19785 -0.12768 0.20327 -0.12878 0.20787 C -0.12904 0.20898 -0.12878 0.21017 -0.12878 0.21136 " pathEditMode="relative" ptsTypes="AAAAAAAAAAAAAAAAAAAAAAAAAAAAAAAAAAAAAAAAAAAAAAAAAAAAAAAAAAAAAAAAA">
+                                      <p:cBhvr>
+                                        <p:cTn id="6" dur="5000" fill="hold"/>
+                                        <p:tgtEl>
+                                          <p:spTgt spid="3"/>
+                                        </p:tgtEl>
+                                        <p:attrNameLst>
+                                          <p:attrName>ppt_x</p:attrName>
+                                          <p:attrName>ppt_y</p:attrName>
+                                        </p:attrNameLst>
+                                      </p:cBhvr>
+                                    </p:animMotion>
+                                  </p:childTnLst>
+                                </p:cTn>
+                              </p:par>
+                            </p:childTnLst>
+                          </p:cTn>
+                        </p:par>
+                        <p:par>
+                          <p:cTn id="7" fill="hold">
+                            <p:stCondLst>
+                              <p:cond delay="5000"/>
+                            </p:stCondLst>
+                            <p:childTnLst>
+                              <p:par>
+                                <p:cTn id="8" presetID="31" presetClass="exit" presetSubtype="0" fill="hold" nodeType="afterEffect">
+                                  <p:stCondLst>
+                                    <p:cond delay="0"/>
+                                  </p:stCondLst>
+                                  <p:childTnLst>
+                                    <p:anim calcmode="lin" valueType="num">
+                                      <p:cBhvr>
+                                        <p:cTn id="9" dur="5000"/>
+                                        <p:tgtEl>
+                                          <p:spTgt spid="3"/>
+                                        </p:tgtEl>
+                                        <p:attrNameLst>
+                                          <p:attrName>ppt_w</p:attrName>
+                                        </p:attrNameLst>
+                                      </p:cBhvr>
+                                      <p:tavLst>
+                                        <p:tav tm="0">
+                                          <p:val>
+                                            <p:strVal val="ppt_w"/>
+                                          </p:val>
+                                        </p:tav>
+                                        <p:tav tm="100000">
+                                          <p:val>
+                                            <p:fltVal val="0"/>
+                                          </p:val>
+                                        </p:tav>
+                                      </p:tavLst>
+                                    </p:anim>
+                                    <p:anim calcmode="lin" valueType="num">
+                                      <p:cBhvr>
+                                        <p:cTn id="10" dur="5000"/>
+                                        <p:tgtEl>
+                                          <p:spTgt spid="3"/>
+                                        </p:tgtEl>
+                                        <p:attrNameLst>
+                                          <p:attrName>ppt_h</p:attrName>
+                                        </p:attrNameLst>
+                                      </p:cBhvr>
+                                      <p:tavLst>
+                                        <p:tav tm="0">
+                                          <p:val>
+                                            <p:strVal val="ppt_h"/>
+                                          </p:val>
+                                        </p:tav>
+                                        <p:tav tm="100000">
+                                          <p:val>
+                                            <p:fltVal val="0"/>
+                                          </p:val>
+                                        </p:tav>
+                                      </p:tavLst>
+                                    </p:anim>
+                                    <p:anim calcmode="lin" valueType="num">
+                                      <p:cBhvr>
+                                        <p:cTn id="11" dur="5000"/>
+                                        <p:tgtEl>
+                                          <p:spTgt spid="3"/>
+                                        </p:tgtEl>
+                                        <p:attrNameLst>
+                                          <p:attrName>style.rotation</p:attrName>
+                                        </p:attrNameLst>
+                                      </p:cBhvr>
+                                      <p:tavLst>
+                                        <p:tav tm="0">
+                                          <p:val>
+                                            <p:fltVal val="0"/>
+                                          </p:val>
+                                        </p:tav>
+                                        <p:tav tm="100000">
+                                          <p:val>
+                                            <p:fltVal val="90"/>
+                                          </p:val>
+                                        </p:tav>
+                                      </p:tavLst>
+                                    </p:anim>
+                                    <p:animEffect transition="out" filter="fade">
+                                      <p:cBhvr>
+                                        <p:cTn id="12" dur="5000"/>
+                                        <p:tgtEl>
+                                          <p:spTgt spid="3"/>
+                                        </p:tgtEl>
+                                      </p:cBhvr>
+                                    </p:animEffect>
+                                    <p:set>
+                                      <p:cBhvr>
+                                        <p:cTn id="13" dur="1" fill="hold">
+                                          <p:stCondLst>
+                                            <p:cond delay="4999"/>
+                                          </p:stCondLst>
+                                        </p:cTn>
+                                        <p:tgtEl>
+                                          <p:spTgt spid="3"/>
+                                        </p:tgtEl>
+                                        <p:attrNameLst>
+                                          <p:attrName>style.visibility</p:attrName>
+                                        </p:attrNameLst>
+                                      </p:cBhvr>
+                                      <p:to>
+                                        <p:strVal val="hidden"/>
+                                      </p:to>
+                                    </p:set>
+                                  </p:childTnLst>
+                                </p:cTn>
+                              </p:par>
+                            </p:childTnLst>
+                          </p:cTn>
+                        </p:par>
+                      </p:childTnLst>
+                    </p:cTn>
+                  </p:par>
+                </p:childTnLst>
+              </p:cTn>
+              <p:prevCondLst>
+                <p:cond evt="onPrev" delay="0">
+                  <p:tgtEl>
+                    <p:sldTgt/>
+                  </p:tgtEl>
+                </p:cond>
+              </p:prevCondLst>
+              <p:nextCondLst>
+                <p:cond evt="onNext" delay="0">
+                  <p:tgtEl>
+                    <p:sldTgt/>
+                  </p:tgtEl>
+                </p:cond>
+              </p:nextCondLst>
+            </p:seq>
+          </p:childTnLst>
+        </p:cTn>
+      </p:par>
+    </p:tnLst>
+  </p:timing>
 </p:sld>
 </file>
 
@@ -2874,26 +3229,6 @@
 </file>
 
 <file path=customXml/item1.xml><?xml version="1.0" encoding="utf-8"?>
-<p:properties xmlns:p="http://schemas.microsoft.com/office/2006/metadata/properties" xmlns:xsi="http://www.w3.org/2001/XMLSchema-instance" xmlns:pc="http://schemas.microsoft.com/office/infopath/2007/PartnerControls">
-  <documentManagement>
-    <lcf76f155ced4ddcb4097134ff3c332f xmlns="139868d9-8e95-45bc-83ba-82132d321acb">
-      <Terms xmlns="http://schemas.microsoft.com/office/infopath/2007/PartnerControls"/>
-    </lcf76f155ced4ddcb4097134ff3c332f>
-    <TaxCatchAll xmlns="2fe66b02-ee31-4649-8513-d45fa9753ec2" xsi:nil="true"/>
-  </documentManagement>
-</p:properties>
-</file>
-
-<file path=customXml/item2.xml><?xml version="1.0" encoding="utf-8"?>
-<?mso-contentType ?>
-<FormTemplates xmlns="http://schemas.microsoft.com/sharepoint/v3/contenttype/forms">
-  <Display>DocumentLibraryForm</Display>
-  <Edit>DocumentLibraryForm</Edit>
-  <New>DocumentLibraryForm</New>
-</FormTemplates>
-</file>
-
-<file path=customXml/item3.xml><?xml version="1.0" encoding="utf-8"?>
 <ct:contentTypeSchema xmlns:ct="http://schemas.microsoft.com/office/2006/metadata/contentType" xmlns:ma="http://schemas.microsoft.com/office/2006/metadata/properties/metaAttributes" ct:_="" ma:_="" ma:contentTypeName="Dokument" ma:contentTypeID="0x0101009D8B956648DEE047ADDF78BFAC90AFFC" ma:contentTypeVersion="18" ma:contentTypeDescription="Ein neues Dokument erstellen." ma:contentTypeScope="" ma:versionID="705f7a7107ac7b18b23cc577bb05ddf6">
   <xsd:schema xmlns:xsd="http://www.w3.org/2001/XMLSchema" xmlns:xs="http://www.w3.org/2001/XMLSchema" xmlns:p="http://schemas.microsoft.com/office/2006/metadata/properties" xmlns:ns2="139868d9-8e95-45bc-83ba-82132d321acb" xmlns:ns3="2fe66b02-ee31-4649-8513-d45fa9753ec2" targetNamespace="http://schemas.microsoft.com/office/2006/metadata/properties" ma:root="true" ma:fieldsID="01357a9511d91edc8d05e21b3f5331ea" ns2:_="" ns3:_="">
     <xsd:import namespace="139868d9-8e95-45bc-83ba-82132d321acb"/>
@@ -3142,26 +3477,27 @@
 </ct:contentTypeSchema>
 </file>
 
-<file path=customXml/itemProps1.xml><?xml version="1.0" encoding="utf-8"?>
-<ds:datastoreItem xmlns:ds="http://schemas.openxmlformats.org/officeDocument/2006/customXml" ds:itemID="{D62D7AF2-5232-40EF-A1E3-8AA6E25B8F43}">
-  <ds:schemaRefs>
-    <ds:schemaRef ds:uri="http://schemas.microsoft.com/office/2006/metadata/properties"/>
-    <ds:schemaRef ds:uri="http://schemas.microsoft.com/office/infopath/2007/PartnerControls"/>
-    <ds:schemaRef ds:uri="139868d9-8e95-45bc-83ba-82132d321acb"/>
-    <ds:schemaRef ds:uri="2fe66b02-ee31-4649-8513-d45fa9753ec2"/>
-  </ds:schemaRefs>
-</ds:datastoreItem>
+<file path=customXml/item2.xml><?xml version="1.0" encoding="utf-8"?>
+<?mso-contentType ?>
+<FormTemplates xmlns="http://schemas.microsoft.com/sharepoint/v3/contenttype/forms">
+  <Display>DocumentLibraryForm</Display>
+  <Edit>DocumentLibraryForm</Edit>
+  <New>DocumentLibraryForm</New>
+</FormTemplates>
 </file>
 
-<file path=customXml/itemProps2.xml><?xml version="1.0" encoding="utf-8"?>
-<ds:datastoreItem xmlns:ds="http://schemas.openxmlformats.org/officeDocument/2006/customXml" ds:itemID="{6B6D7A92-1D2B-48B1-97EB-1199B4F809F0}">
-  <ds:schemaRefs>
-    <ds:schemaRef ds:uri="http://schemas.microsoft.com/sharepoint/v3/contenttype/forms"/>
-  </ds:schemaRefs>
-</ds:datastoreItem>
+<file path=customXml/item3.xml><?xml version="1.0" encoding="utf-8"?>
+<p:properties xmlns:p="http://schemas.microsoft.com/office/2006/metadata/properties" xmlns:xsi="http://www.w3.org/2001/XMLSchema-instance" xmlns:pc="http://schemas.microsoft.com/office/infopath/2007/PartnerControls">
+  <documentManagement>
+    <lcf76f155ced4ddcb4097134ff3c332f xmlns="139868d9-8e95-45bc-83ba-82132d321acb">
+      <Terms xmlns="http://schemas.microsoft.com/office/infopath/2007/PartnerControls"/>
+    </lcf76f155ced4ddcb4097134ff3c332f>
+    <TaxCatchAll xmlns="2fe66b02-ee31-4649-8513-d45fa9753ec2" xsi:nil="true"/>
+  </documentManagement>
+</p:properties>
 </file>
 
-<file path=customXml/itemProps3.xml><?xml version="1.0" encoding="utf-8"?>
+<file path=customXml/itemProps1.xml><?xml version="1.0" encoding="utf-8"?>
 <ds:datastoreItem xmlns:ds="http://schemas.openxmlformats.org/officeDocument/2006/customXml" ds:itemID="{B855B245-999C-4603-8602-25F7F80FC034}">
   <ds:schemaRefs>
     <ds:schemaRef ds:uri="http://schemas.microsoft.com/office/2006/metadata/contentType"/>
@@ -3178,4 +3514,23 @@
     <ds:schemaRef ds:uri="http://schemas.microsoft.com/internal/obd"/>
   </ds:schemaRefs>
 </ds:datastoreItem>
+</file>
+
+<file path=customXml/itemProps2.xml><?xml version="1.0" encoding="utf-8"?>
+<ds:datastoreItem xmlns:ds="http://schemas.openxmlformats.org/officeDocument/2006/customXml" ds:itemID="{6B6D7A92-1D2B-48B1-97EB-1199B4F809F0}">
+  <ds:schemaRefs>
+    <ds:schemaRef ds:uri="http://schemas.microsoft.com/sharepoint/v3/contenttype/forms"/>
+  </ds:schemaRefs>
+</ds:datastoreItem>
+</file>
+
+<file path=customXml/itemProps3.xml><?xml version="1.0" encoding="utf-8"?>
+<ds:datastoreItem xmlns:ds="http://schemas.openxmlformats.org/officeDocument/2006/customXml" ds:itemID="{D62D7AF2-5232-40EF-A1E3-8AA6E25B8F43}">
+  <ds:schemaRefs>
+    <ds:schemaRef ds:uri="http://schemas.microsoft.com/office/2006/metadata/properties"/>
+    <ds:schemaRef ds:uri="http://schemas.microsoft.com/office/infopath/2007/PartnerControls"/>
+    <ds:schemaRef ds:uri="139868d9-8e95-45bc-83ba-82132d321acb"/>
+    <ds:schemaRef ds:uri="2fe66b02-ee31-4649-8513-d45fa9753ec2"/>
+  </ds:schemaRefs>
+</ds:datastoreItem>
 </file>
</xml_diff>